<commit_message>
Refresh Lecture 5 review with game-score data
Replaced the old Faithful-based Lecture 5 review example with a reproducible sample of Metacritic video game critic scores. The figure generator now reads a new `video_game_critic_scores.csv`, creates an additional raw-data games table image, updates binning/labels/check outputs, and regenerates the review dotplot, histogram, and frequency table. Week 2 Lecture 5 slide files (PPTX/PDF) were updated to use the new visuals and narrative.
</commit_message>
<xml_diff>
--- a/docs/lecture_slides/Week 2/Week2_Lecture5_slides_1_19_2024.pptx
+++ b/docs/lecture_slides/Week 2/Week2_Lecture5_slides_1_19_2024.pptx
@@ -3636,7 +3636,7 @@
     </p:spTree>
     <p:extLst>
       <p:ext uri="{BB962C8B-B14F-4D97-AF65-F5344CB8AC3E}">
-        <p14:creationId xmlns:p14="http://schemas.microsoft.com/office/powerpoint/2010/main" val="2882306300"/>
+        <p14:creationId xmlns:p14="http://schemas.microsoft.com/office/powerpoint/2010/main" val="1872709583"/>
       </p:ext>
     </p:extLst>
   </p:cSld>
@@ -3784,7 +3784,7 @@
     </p:spTree>
     <p:extLst>
       <p:ext uri="{BB962C8B-B14F-4D97-AF65-F5344CB8AC3E}">
-        <p14:creationId xmlns:p14="http://schemas.microsoft.com/office/powerpoint/2010/main" val="2433185399"/>
+        <p14:creationId xmlns:p14="http://schemas.microsoft.com/office/powerpoint/2010/main" val="1462869705"/>
       </p:ext>
     </p:extLst>
   </p:cSld>
@@ -4816,7 +4816,7 @@
     </p:spTree>
     <p:extLst>
       <p:ext uri="{BB962C8B-B14F-4D97-AF65-F5344CB8AC3E}">
-        <p14:creationId xmlns:p14="http://schemas.microsoft.com/office/powerpoint/2010/main" val="1661603988"/>
+        <p14:creationId xmlns:p14="http://schemas.microsoft.com/office/powerpoint/2010/main" val="165304605"/>
       </p:ext>
     </p:extLst>
   </p:cSld>
@@ -4958,7 +4958,7 @@
     </p:spTree>
     <p:extLst>
       <p:ext uri="{BB962C8B-B14F-4D97-AF65-F5344CB8AC3E}">
-        <p14:creationId xmlns:p14="http://schemas.microsoft.com/office/powerpoint/2010/main" val="4170938275"/>
+        <p14:creationId xmlns:p14="http://schemas.microsoft.com/office/powerpoint/2010/main" val="2940681080"/>
       </p:ext>
     </p:extLst>
   </p:cSld>
@@ -5018,7 +5018,7 @@
     </p:spTree>
     <p:extLst>
       <p:ext uri="{BB962C8B-B14F-4D97-AF65-F5344CB8AC3E}">
-        <p14:creationId xmlns:p14="http://schemas.microsoft.com/office/powerpoint/2010/main" val="587893769"/>
+        <p14:creationId xmlns:p14="http://schemas.microsoft.com/office/powerpoint/2010/main" val="2134092552"/>
       </p:ext>
     </p:extLst>
   </p:cSld>
@@ -5426,7 +5426,7 @@
     </p:spTree>
     <p:extLst>
       <p:ext uri="{BB962C8B-B14F-4D97-AF65-F5344CB8AC3E}">
-        <p14:creationId xmlns:p14="http://schemas.microsoft.com/office/powerpoint/2010/main" val="3372766809"/>
+        <p14:creationId xmlns:p14="http://schemas.microsoft.com/office/powerpoint/2010/main" val="1672991489"/>
       </p:ext>
     </p:extLst>
   </p:cSld>
@@ -5995,7 +5995,7 @@
     </p:spTree>
     <p:extLst>
       <p:ext uri="{BB962C8B-B14F-4D97-AF65-F5344CB8AC3E}">
-        <p14:creationId xmlns:p14="http://schemas.microsoft.com/office/powerpoint/2010/main" val="3474604953"/>
+        <p14:creationId xmlns:p14="http://schemas.microsoft.com/office/powerpoint/2010/main" val="1737068264"/>
       </p:ext>
     </p:extLst>
   </p:cSld>
@@ -6910,7 +6910,7 @@
     </p:spTree>
     <p:extLst>
       <p:ext uri="{BB962C8B-B14F-4D97-AF65-F5344CB8AC3E}">
-        <p14:creationId xmlns:p14="http://schemas.microsoft.com/office/powerpoint/2010/main" val="1866486794"/>
+        <p14:creationId xmlns:p14="http://schemas.microsoft.com/office/powerpoint/2010/main" val="2465021212"/>
       </p:ext>
     </p:extLst>
   </p:cSld>
@@ -7386,7 +7386,7 @@
     </p:spTree>
     <p:extLst>
       <p:ext uri="{BB962C8B-B14F-4D97-AF65-F5344CB8AC3E}">
-        <p14:creationId xmlns:p14="http://schemas.microsoft.com/office/powerpoint/2010/main" val="3381239205"/>
+        <p14:creationId xmlns:p14="http://schemas.microsoft.com/office/powerpoint/2010/main" val="2075252588"/>
       </p:ext>
     </p:extLst>
   </p:cSld>
@@ -7701,7 +7701,7 @@
     </p:spTree>
     <p:extLst>
       <p:ext uri="{BB962C8B-B14F-4D97-AF65-F5344CB8AC3E}">
-        <p14:creationId xmlns:p14="http://schemas.microsoft.com/office/powerpoint/2010/main" val="275491056"/>
+        <p14:creationId xmlns:p14="http://schemas.microsoft.com/office/powerpoint/2010/main" val="3043135837"/>
       </p:ext>
     </p:extLst>
   </p:cSld>
@@ -9130,7 +9130,7 @@
     </p:spTree>
     <p:extLst>
       <p:ext uri="{BB962C8B-B14F-4D97-AF65-F5344CB8AC3E}">
-        <p14:creationId xmlns:p14="http://schemas.microsoft.com/office/powerpoint/2010/main" val="2860374262"/>
+        <p14:creationId xmlns:p14="http://schemas.microsoft.com/office/powerpoint/2010/main" val="1339374432"/>
       </p:ext>
     </p:extLst>
   </p:cSld>
@@ -9398,7 +9398,7 @@
     </p:spTree>
     <p:extLst>
       <p:ext uri="{BB962C8B-B14F-4D97-AF65-F5344CB8AC3E}">
-        <p14:creationId xmlns:p14="http://schemas.microsoft.com/office/powerpoint/2010/main" val="1181264920"/>
+        <p14:creationId xmlns:p14="http://schemas.microsoft.com/office/powerpoint/2010/main" val="1025040394"/>
       </p:ext>
     </p:extLst>
   </p:cSld>
@@ -10886,7 +10886,7 @@
     </p:spTree>
     <p:extLst>
       <p:ext uri="{BB962C8B-B14F-4D97-AF65-F5344CB8AC3E}">
-        <p14:creationId xmlns:p14="http://schemas.microsoft.com/office/powerpoint/2010/main" val="3969543990"/>
+        <p14:creationId xmlns:p14="http://schemas.microsoft.com/office/powerpoint/2010/main" val="919873286"/>
       </p:ext>
     </p:extLst>
   </p:cSld>
@@ -11011,7 +11011,7 @@
     </p:spTree>
     <p:extLst>
       <p:ext uri="{BB962C8B-B14F-4D97-AF65-F5344CB8AC3E}">
-        <p14:creationId xmlns:p14="http://schemas.microsoft.com/office/powerpoint/2010/main" val="2328300319"/>
+        <p14:creationId xmlns:p14="http://schemas.microsoft.com/office/powerpoint/2010/main" val="4076174346"/>
       </p:ext>
     </p:extLst>
   </p:cSld>
@@ -11099,7 +11099,7 @@
     </p:spTree>
     <p:extLst>
       <p:ext uri="{BB962C8B-B14F-4D97-AF65-F5344CB8AC3E}">
-        <p14:creationId xmlns:p14="http://schemas.microsoft.com/office/powerpoint/2010/main" val="1985037083"/>
+        <p14:creationId xmlns:p14="http://schemas.microsoft.com/office/powerpoint/2010/main" val="1917626945"/>
       </p:ext>
     </p:extLst>
   </p:cSld>
@@ -11315,7 +11315,7 @@
     </p:spTree>
     <p:extLst>
       <p:ext uri="{BB962C8B-B14F-4D97-AF65-F5344CB8AC3E}">
-        <p14:creationId xmlns:p14="http://schemas.microsoft.com/office/powerpoint/2010/main" val="751844891"/>
+        <p14:creationId xmlns:p14="http://schemas.microsoft.com/office/powerpoint/2010/main" val="3336169193"/>
       </p:ext>
     </p:extLst>
   </p:cSld>
@@ -11569,7 +11569,7 @@
     </p:spTree>
     <p:extLst>
       <p:ext uri="{BB962C8B-B14F-4D97-AF65-F5344CB8AC3E}">
-        <p14:creationId xmlns:p14="http://schemas.microsoft.com/office/powerpoint/2010/main" val="2757094478"/>
+        <p14:creationId xmlns:p14="http://schemas.microsoft.com/office/powerpoint/2010/main" val="3939556708"/>
       </p:ext>
     </p:extLst>
   </p:cSld>
@@ -11673,7 +11673,7 @@
     </p:spTree>
     <p:extLst>
       <p:ext uri="{BB962C8B-B14F-4D97-AF65-F5344CB8AC3E}">
-        <p14:creationId xmlns:p14="http://schemas.microsoft.com/office/powerpoint/2010/main" val="453027852"/>
+        <p14:creationId xmlns:p14="http://schemas.microsoft.com/office/powerpoint/2010/main" val="236921382"/>
       </p:ext>
     </p:extLst>
   </p:cSld>
@@ -11853,7 +11853,7 @@
     </p:spTree>
     <p:extLst>
       <p:ext uri="{BB962C8B-B14F-4D97-AF65-F5344CB8AC3E}">
-        <p14:creationId xmlns:p14="http://schemas.microsoft.com/office/powerpoint/2010/main" val="1844292270"/>
+        <p14:creationId xmlns:p14="http://schemas.microsoft.com/office/powerpoint/2010/main" val="1386231900"/>
       </p:ext>
     </p:extLst>
   </p:cSld>
@@ -11913,7 +11913,7 @@
     </p:spTree>
     <p:extLst>
       <p:ext uri="{BB962C8B-B14F-4D97-AF65-F5344CB8AC3E}">
-        <p14:creationId xmlns:p14="http://schemas.microsoft.com/office/powerpoint/2010/main" val="2458905175"/>
+        <p14:creationId xmlns:p14="http://schemas.microsoft.com/office/powerpoint/2010/main" val="867768209"/>
       </p:ext>
     </p:extLst>
   </p:cSld>
@@ -11945,7 +11945,7 @@
           <p:cNvPr id="2" name="Title 1">
             <a:extLst>
               <a:ext uri="{FF2B5EF4-FFF2-40B4-BE49-F238E27FC236}">
-                <a16:creationId xmlns:a16="http://schemas.microsoft.com/office/drawing/2014/main" id="{E2F05537-368C-F876-2D38-F08825FC2E07}"/>
+                <a16:creationId xmlns:a16="http://schemas.microsoft.com/office/drawing/2014/main" id="{602EA695-3AC8-A481-E49D-28C2DE376D09}"/>
               </a:ext>
             </a:extLst>
           </p:cNvPr>
@@ -11963,7 +11963,7 @@
           <a:p>
             <a:r>
               <a:rPr lang="en-US"/>
-              <a:t>Review: one small dataset</a:t>
+              <a:t>Review: ten video games</a:t>
             </a:r>
           </a:p>
         </p:txBody>
@@ -11973,7 +11973,7 @@
           <p:cNvPr id="3" name="Content Placeholder 2">
             <a:extLst>
               <a:ext uri="{FF2B5EF4-FFF2-40B4-BE49-F238E27FC236}">
-                <a16:creationId xmlns:a16="http://schemas.microsoft.com/office/drawing/2014/main" id="{BA2DD419-6B4D-A2B7-82E5-B99E445B4F74}"/>
+                <a16:creationId xmlns:a16="http://schemas.microsoft.com/office/drawing/2014/main" id="{21B7095C-11DB-7936-5FB4-845A466B7D33}"/>
               </a:ext>
             </a:extLst>
           </p:cNvPr>
@@ -11986,8 +11986,8 @@
         </p:nvSpPr>
         <p:spPr>
           <a:xfrm>
-            <a:off x="762000" y="1270000"/>
-            <a:ext cx="10795000" cy="584200"/>
+            <a:off x="762000" y="1244600"/>
+            <a:ext cx="10795000" cy="482600"/>
           </a:xfrm>
         </p:spPr>
         <p:txBody>
@@ -12001,7 +12001,7 @@
             </a:pPr>
             <a:r>
               <a:rPr lang="en-US" sz="1600"/>
-              <a:t>x = waiting time between eruptions of Old Faithful (minutes), for a random sample of n = 10 eruptions.</a:t>
+              <a:t>x = Metacritic critic score, for a random sample of n = 10 best-selling video games.</a:t>
             </a:r>
           </a:p>
         </p:txBody>
@@ -12011,7 +12011,7 @@
           <p:cNvPr id="4" name="Values">
             <a:extLst>
               <a:ext uri="{FF2B5EF4-FFF2-40B4-BE49-F238E27FC236}">
-                <a16:creationId xmlns:a16="http://schemas.microsoft.com/office/drawing/2014/main" id="{89593ED8-70E3-F0EB-DE16-964F6188179E}"/>
+                <a16:creationId xmlns:a16="http://schemas.microsoft.com/office/drawing/2014/main" id="{843B934A-AF59-02EF-8995-47A653C8EF1E}"/>
               </a:ext>
             </a:extLst>
           </p:cNvPr>
@@ -12020,8 +12020,8 @@
         </p:nvSpPr>
         <p:spPr>
           <a:xfrm>
-            <a:off x="762000" y="1854200"/>
-            <a:ext cx="10795000" cy="369332"/>
+            <a:off x="762000" y="1752600"/>
+            <a:ext cx="10795000" cy="381000"/>
           </a:xfrm>
           <a:prstGeom prst="rect">
             <a:avLst/>
@@ -12038,7 +12038,7 @@
               <a:rPr lang="en-US" b="1">
                 <a:latin typeface="Consolas" panose="020B0609020204030204" pitchFamily="49" charset="0"/>
               </a:rPr>
-              <a:t>x = { 45,  51,  52,  56,  77,  78,  78,  78,  79,  84 }</a:t>
+              <a:t>x = { 68,  72,  76,  76,  76,  83,  85,  87,  92,  95 }</a:t>
             </a:r>
           </a:p>
         </p:txBody>
@@ -12048,7 +12048,7 @@
           <p:cNvPr id="6" name="Picture 5">
             <a:extLst>
               <a:ext uri="{FF2B5EF4-FFF2-40B4-BE49-F238E27FC236}">
-                <a16:creationId xmlns:a16="http://schemas.microsoft.com/office/drawing/2014/main" id="{11726840-09C8-C9CB-EB29-3C6605F538AA}"/>
+                <a16:creationId xmlns:a16="http://schemas.microsoft.com/office/drawing/2014/main" id="{00A12CEC-6AE4-7530-386E-A62105F9D069}"/>
               </a:ext>
             </a:extLst>
           </p:cNvPr>
@@ -12071,8 +12071,44 @@
         </p:blipFill>
         <p:spPr>
           <a:xfrm>
-            <a:off x="2159000" y="2438400"/>
-            <a:ext cx="7874000" cy="3505200"/>
+            <a:off x="508000" y="2235200"/>
+            <a:ext cx="5969000" cy="3708400"/>
+          </a:xfrm>
+          <a:prstGeom prst="rect">
+            <a:avLst/>
+          </a:prstGeom>
+        </p:spPr>
+      </p:pic>
+      <p:pic>
+        <p:nvPicPr>
+          <p:cNvPr id="8" name="Picture 7">
+            <a:extLst>
+              <a:ext uri="{FF2B5EF4-FFF2-40B4-BE49-F238E27FC236}">
+                <a16:creationId xmlns:a16="http://schemas.microsoft.com/office/drawing/2014/main" id="{03F605A8-66A2-41B0-4B9F-85FA855F95A2}"/>
+              </a:ext>
+            </a:extLst>
+          </p:cNvPr>
+          <p:cNvPicPr>
+            <a:picLocks/>
+          </p:cNvPicPr>
+          <p:nvPr/>
+        </p:nvPicPr>
+        <p:blipFill>
+          <a:blip r:embed="rId3">
+            <a:extLst>
+              <a:ext uri="{28A0092B-C50C-407E-A947-70E740481C1C}">
+                <a14:useLocalDpi xmlns:a14="http://schemas.microsoft.com/office/drawing/2010/main" val="0"/>
+              </a:ext>
+            </a:extLst>
+          </a:blip>
+          <a:stretch>
+            <a:fillRect/>
+          </a:stretch>
+        </p:blipFill>
+        <p:spPr>
+          <a:xfrm>
+            <a:off x="6858000" y="2235200"/>
+            <a:ext cx="4826000" cy="2349500"/>
           </a:xfrm>
           <a:prstGeom prst="rect">
             <a:avLst/>
@@ -12081,10 +12117,10 @@
       </p:pic>
       <p:sp>
         <p:nvSpPr>
-          <p:cNvPr id="7" name="TextBox 6">
+          <p:cNvPr id="9" name="TextBox 8">
             <a:extLst>
               <a:ext uri="{FF2B5EF4-FFF2-40B4-BE49-F238E27FC236}">
-                <a16:creationId xmlns:a16="http://schemas.microsoft.com/office/drawing/2014/main" id="{267B0811-F0B8-E752-BDB3-0897DFC6CDF7}"/>
+                <a16:creationId xmlns:a16="http://schemas.microsoft.com/office/drawing/2014/main" id="{CE541DD7-04E3-2643-4511-B3A7406B9876}"/>
               </a:ext>
             </a:extLst>
           </p:cNvPr>
@@ -12093,8 +12129,43 @@
         </p:nvSpPr>
         <p:spPr>
           <a:xfrm>
-            <a:off x="762000" y="6070600"/>
-            <a:ext cx="10795000" cy="307777"/>
+            <a:off x="6858000" y="4800600"/>
+            <a:ext cx="4826000" cy="492443"/>
+          </a:xfrm>
+          <a:prstGeom prst="rect">
+            <a:avLst/>
+          </a:prstGeom>
+          <a:noFill/>
+        </p:spPr>
+        <p:txBody>
+          <a:bodyPr vert="horz" wrap="square" rtlCol="0">
+            <a:spAutoFit/>
+          </a:bodyPr>
+          <a:lstStyle/>
+          <a:p>
+            <a:r>
+              <a:rPr lang="en-US" sz="1300" i="1"/>
+              <a:t>Four bins of width 10. Most of these games score in the 70s, with a few running up into the 90s.</a:t>
+            </a:r>
+          </a:p>
+        </p:txBody>
+      </p:sp>
+      <p:sp>
+        <p:nvSpPr>
+          <p:cNvPr id="10" name="TextBox 9">
+            <a:extLst>
+              <a:ext uri="{FF2B5EF4-FFF2-40B4-BE49-F238E27FC236}">
+                <a16:creationId xmlns:a16="http://schemas.microsoft.com/office/drawing/2014/main" id="{BD195836-C2AF-8978-1148-2171E77D2E25}"/>
+              </a:ext>
+            </a:extLst>
+          </p:cNvPr>
+          <p:cNvSpPr txBox="1"/>
+          <p:nvPr/>
+        </p:nvSpPr>
+        <p:spPr>
+          <a:xfrm>
+            <a:off x="508000" y="6451600"/>
+            <a:ext cx="11176000" cy="246221"/>
           </a:xfrm>
           <a:prstGeom prst="rect">
             <a:avLst/>
@@ -12108,8 +12179,12 @@
           <a:lstStyle/>
           <a:p>
             <a:r>
-              <a:rPr lang="en-US" sz="1400" i="1"/>
-              <a:t>Five bins of width 10. Notice the bin that came out empty.</a:t>
+              <a:rPr lang="en-US" sz="1000" i="1">
+                <a:solidFill>
+                  <a:srgbClr val="666666"/>
+                </a:solidFill>
+              </a:rPr>
+              <a:t>Data: VGChartz sales joined to Metacritic ratings, restricted to titles selling 5 million copies or more (127 games).</a:t>
             </a:r>
           </a:p>
         </p:txBody>
@@ -12117,7 +12192,7 @@
     </p:spTree>
     <p:extLst>
       <p:ext uri="{BB962C8B-B14F-4D97-AF65-F5344CB8AC3E}">
-        <p14:creationId xmlns:p14="http://schemas.microsoft.com/office/powerpoint/2010/main" val="1881088174"/>
+        <p14:creationId xmlns:p14="http://schemas.microsoft.com/office/powerpoint/2010/main" val="3538760259"/>
       </p:ext>
     </p:extLst>
   </p:cSld>
@@ -13414,7 +13489,7 @@
     </p:spTree>
     <p:extLst>
       <p:ext uri="{BB962C8B-B14F-4D97-AF65-F5344CB8AC3E}">
-        <p14:creationId xmlns:p14="http://schemas.microsoft.com/office/powerpoint/2010/main" val="3888045774"/>
+        <p14:creationId xmlns:p14="http://schemas.microsoft.com/office/powerpoint/2010/main" val="1205830479"/>
       </p:ext>
     </p:extLst>
   </p:cSld>
@@ -13524,7 +13599,7 @@
     </p:spTree>
     <p:extLst>
       <p:ext uri="{BB962C8B-B14F-4D97-AF65-F5344CB8AC3E}">
-        <p14:creationId xmlns:p14="http://schemas.microsoft.com/office/powerpoint/2010/main" val="3907875898"/>
+        <p14:creationId xmlns:p14="http://schemas.microsoft.com/office/powerpoint/2010/main" val="722022185"/>
       </p:ext>
     </p:extLst>
   </p:cSld>
@@ -13664,7 +13739,7 @@
     </p:spTree>
     <p:extLst>
       <p:ext uri="{BB962C8B-B14F-4D97-AF65-F5344CB8AC3E}">
-        <p14:creationId xmlns:p14="http://schemas.microsoft.com/office/powerpoint/2010/main" val="2998955756"/>
+        <p14:creationId xmlns:p14="http://schemas.microsoft.com/office/powerpoint/2010/main" val="461962410"/>
       </p:ext>
     </p:extLst>
   </p:cSld>
@@ -13968,7 +14043,7 @@
     </p:spTree>
     <p:extLst>
       <p:ext uri="{BB962C8B-B14F-4D97-AF65-F5344CB8AC3E}">
-        <p14:creationId xmlns:p14="http://schemas.microsoft.com/office/powerpoint/2010/main" val="1845746374"/>
+        <p14:creationId xmlns:p14="http://schemas.microsoft.com/office/powerpoint/2010/main" val="1347518694"/>
       </p:ext>
     </p:extLst>
   </p:cSld>
@@ -14551,7 +14626,7 @@
     </p:spTree>
     <p:extLst>
       <p:ext uri="{BB962C8B-B14F-4D97-AF65-F5344CB8AC3E}">
-        <p14:creationId xmlns:p14="http://schemas.microsoft.com/office/powerpoint/2010/main" val="1489309008"/>
+        <p14:creationId xmlns:p14="http://schemas.microsoft.com/office/powerpoint/2010/main" val="745170016"/>
       </p:ext>
     </p:extLst>
   </p:cSld>
@@ -15309,7 +15384,7 @@
     </p:spTree>
     <p:extLst>
       <p:ext uri="{BB962C8B-B14F-4D97-AF65-F5344CB8AC3E}">
-        <p14:creationId xmlns:p14="http://schemas.microsoft.com/office/powerpoint/2010/main" val="301570501"/>
+        <p14:creationId xmlns:p14="http://schemas.microsoft.com/office/powerpoint/2010/main" val="3613932169"/>
       </p:ext>
     </p:extLst>
   </p:cSld>
@@ -15780,7 +15855,7 @@
     </p:spTree>
     <p:extLst>
       <p:ext uri="{BB962C8B-B14F-4D97-AF65-F5344CB8AC3E}">
-        <p14:creationId xmlns:p14="http://schemas.microsoft.com/office/powerpoint/2010/main" val="347452439"/>
+        <p14:creationId xmlns:p14="http://schemas.microsoft.com/office/powerpoint/2010/main" val="2779751728"/>
       </p:ext>
     </p:extLst>
   </p:cSld>
@@ -16144,7 +16219,7 @@
     </p:spTree>
     <p:extLst>
       <p:ext uri="{BB962C8B-B14F-4D97-AF65-F5344CB8AC3E}">
-        <p14:creationId xmlns:p14="http://schemas.microsoft.com/office/powerpoint/2010/main" val="1627617725"/>
+        <p14:creationId xmlns:p14="http://schemas.microsoft.com/office/powerpoint/2010/main" val="253553745"/>
       </p:ext>
     </p:extLst>
   </p:cSld>
@@ -17101,7 +17176,7 @@
     </p:spTree>
     <p:extLst>
       <p:ext uri="{BB962C8B-B14F-4D97-AF65-F5344CB8AC3E}">
-        <p14:creationId xmlns:p14="http://schemas.microsoft.com/office/powerpoint/2010/main" val="2606279526"/>
+        <p14:creationId xmlns:p14="http://schemas.microsoft.com/office/powerpoint/2010/main" val="3275667608"/>
       </p:ext>
     </p:extLst>
   </p:cSld>
@@ -17133,7 +17208,7 @@
           <p:cNvPr id="2" name="Title 1">
             <a:extLst>
               <a:ext uri="{FF2B5EF4-FFF2-40B4-BE49-F238E27FC236}">
-                <a16:creationId xmlns:a16="http://schemas.microsoft.com/office/drawing/2014/main" id="{9CB0ADC1-B5BD-B5C2-B389-C675FC3679A9}"/>
+                <a16:creationId xmlns:a16="http://schemas.microsoft.com/office/drawing/2014/main" id="{2F7BD5D9-2535-EECF-DCF2-5C4D1AA7FF27}"/>
               </a:ext>
             </a:extLst>
           </p:cNvPr>
@@ -17161,7 +17236,7 @@
           <p:cNvPr id="3" name="Content Placeholder 2">
             <a:extLst>
               <a:ext uri="{FF2B5EF4-FFF2-40B4-BE49-F238E27FC236}">
-                <a16:creationId xmlns:a16="http://schemas.microsoft.com/office/drawing/2014/main" id="{1CB34267-EDAB-874B-71BA-FA862A615CA5}"/>
+                <a16:creationId xmlns:a16="http://schemas.microsoft.com/office/drawing/2014/main" id="{7352D86D-59F2-0877-48AC-A1FA29DA7BA6}"/>
               </a:ext>
             </a:extLst>
           </p:cNvPr>
@@ -17200,7 +17275,7 @@
               <a:rPr lang="en-US" sz="1600">
                 <a:latin typeface="Consolas" panose="020B0609020204030204" pitchFamily="49" charset="0"/>
               </a:rPr>
-              <a:t>x = { 45,  51,  52,  56,  77,  78,  78,  78,  79,  84 }</a:t>
+              <a:t>x = { 68,  72,  76,  76,  76,  83,  85,  87,  92,  95 }</a:t>
             </a:r>
           </a:p>
         </p:txBody>
@@ -17210,7 +17285,7 @@
           <p:cNvPr id="5" name="Picture 4">
             <a:extLst>
               <a:ext uri="{FF2B5EF4-FFF2-40B4-BE49-F238E27FC236}">
-                <a16:creationId xmlns:a16="http://schemas.microsoft.com/office/drawing/2014/main" id="{B7850916-1C01-F2B8-D474-3083FD62C858}"/>
+                <a16:creationId xmlns:a16="http://schemas.microsoft.com/office/drawing/2014/main" id="{144AAA1B-CC9B-B135-0C5F-539FEB542E6D}"/>
               </a:ext>
             </a:extLst>
           </p:cNvPr>
@@ -17244,7 +17319,7 @@
     </p:spTree>
     <p:extLst>
       <p:ext uri="{BB962C8B-B14F-4D97-AF65-F5344CB8AC3E}">
-        <p14:creationId xmlns:p14="http://schemas.microsoft.com/office/powerpoint/2010/main" val="413037631"/>
+        <p14:creationId xmlns:p14="http://schemas.microsoft.com/office/powerpoint/2010/main" val="4132901345"/>
       </p:ext>
     </p:extLst>
   </p:cSld>
@@ -17410,7 +17485,7 @@
           <p:cNvPr id="2" name="Title 1">
             <a:extLst>
               <a:ext uri="{FF2B5EF4-FFF2-40B4-BE49-F238E27FC236}">
-                <a16:creationId xmlns:a16="http://schemas.microsoft.com/office/drawing/2014/main" id="{8F6611E1-F939-75B7-626B-3C25B95DF48D}"/>
+                <a16:creationId xmlns:a16="http://schemas.microsoft.com/office/drawing/2014/main" id="{5F0475DD-C30A-CE5B-5EDC-FB6630F130AE}"/>
               </a:ext>
             </a:extLst>
           </p:cNvPr>
@@ -17438,7 +17513,7 @@
           <p:cNvPr id="3" name="Content Placeholder 2">
             <a:extLst>
               <a:ext uri="{FF2B5EF4-FFF2-40B4-BE49-F238E27FC236}">
-                <a16:creationId xmlns:a16="http://schemas.microsoft.com/office/drawing/2014/main" id="{DCB68017-25CA-2491-A25A-42EE761B4CC6}"/>
+                <a16:creationId xmlns:a16="http://schemas.microsoft.com/office/drawing/2014/main" id="{7A65835C-7512-11EE-A3ED-D5A3584C0CA8}"/>
               </a:ext>
             </a:extLst>
           </p:cNvPr>
@@ -17477,7 +17552,7 @@
               <a:rPr lang="en-US" sz="1600">
                 <a:latin typeface="Consolas" panose="020B0609020204030204" pitchFamily="49" charset="0"/>
               </a:rPr>
-              <a:t>x = { 45,  51,  52,  56,  77,  78,  78,  78,  79,  84 }</a:t>
+              <a:t>x = { 68,  72,  76,  76,  76,  83,  85,  87,  92,  95 }</a:t>
             </a:r>
           </a:p>
         </p:txBody>
@@ -17487,7 +17562,7 @@
           <p:cNvPr id="4" name="Stem and leaf">
             <a:extLst>
               <a:ext uri="{FF2B5EF4-FFF2-40B4-BE49-F238E27FC236}">
-                <a16:creationId xmlns:a16="http://schemas.microsoft.com/office/drawing/2014/main" id="{27EDD21C-3939-195D-582C-7D48A4577E52}"/>
+                <a16:creationId xmlns:a16="http://schemas.microsoft.com/office/drawing/2014/main" id="{989826F4-77DC-8262-AD82-17EC8B1B478C}"/>
               </a:ext>
             </a:extLst>
           </p:cNvPr>
@@ -17497,7 +17572,7 @@
         <p:spPr>
           <a:xfrm>
             <a:off x="3810000" y="2667000"/>
-            <a:ext cx="4826000" cy="2862322"/>
+            <a:ext cx="4826000" cy="2554545"/>
           </a:xfrm>
           <a:prstGeom prst="rect">
             <a:avLst/>
@@ -17522,7 +17597,7 @@
               <a:rPr lang="en-US" sz="2000">
                 <a:latin typeface="Consolas" panose="020B0609020204030204" pitchFamily="49" charset="0"/>
               </a:rPr>
-              <a:t>-----+---------</a:t>
+              <a:t>-----+------------</a:t>
             </a:r>
           </a:p>
           <a:p>
@@ -17530,7 +17605,7 @@
               <a:rPr lang="en-US" sz="2000">
                 <a:latin typeface="Consolas" panose="020B0609020204030204" pitchFamily="49" charset="0"/>
               </a:rPr>
-              <a:t>   4 | 5</a:t>
+              <a:t>   6 | 8</a:t>
             </a:r>
           </a:p>
           <a:p>
@@ -17538,7 +17613,7 @@
               <a:rPr lang="en-US" sz="2000">
                 <a:latin typeface="Consolas" panose="020B0609020204030204" pitchFamily="49" charset="0"/>
               </a:rPr>
-              <a:t>   5 | 1  2  6</a:t>
+              <a:t>   7 | 2  6  6  6</a:t>
             </a:r>
           </a:p>
           <a:p>
@@ -17546,7 +17621,7 @@
               <a:rPr lang="en-US" sz="2000">
                 <a:latin typeface="Consolas" panose="020B0609020204030204" pitchFamily="49" charset="0"/>
               </a:rPr>
-              <a:t>   6 |</a:t>
+              <a:t>   8 | 3  5  7</a:t>
             </a:r>
           </a:p>
           <a:p>
@@ -17554,28 +17629,20 @@
               <a:rPr lang="en-US" sz="2000">
                 <a:latin typeface="Consolas" panose="020B0609020204030204" pitchFamily="49" charset="0"/>
               </a:rPr>
-              <a:t>   7 | 7  8  8  8  9</a:t>
-            </a:r>
+              <a:t>   9 | 2  5</a:t>
+            </a:r>
+          </a:p>
+          <a:p>
+            <a:endParaRPr lang="en-US" sz="2000">
+              <a:latin typeface="Consolas" panose="020B0609020204030204" pitchFamily="49" charset="0"/>
+            </a:endParaRPr>
           </a:p>
           <a:p>
             <a:r>
               <a:rPr lang="en-US" sz="2000">
                 <a:latin typeface="Consolas" panose="020B0609020204030204" pitchFamily="49" charset="0"/>
               </a:rPr>
-              <a:t>   8 | 4</a:t>
-            </a:r>
-          </a:p>
-          <a:p>
-            <a:endParaRPr lang="en-US" sz="2000">
-              <a:latin typeface="Consolas" panose="020B0609020204030204" pitchFamily="49" charset="0"/>
-            </a:endParaRPr>
-          </a:p>
-          <a:p>
-            <a:r>
-              <a:rPr lang="en-US" sz="2000">
-                <a:latin typeface="Consolas" panose="020B0609020204030204" pitchFamily="49" charset="0"/>
-              </a:rPr>
-              <a:t>Key:  4 | 5  =  45 minutes</a:t>
+              <a:t>Key:  6 | 8  =  68</a:t>
             </a:r>
           </a:p>
         </p:txBody>
@@ -17583,7 +17650,7 @@
     </p:spTree>
     <p:extLst>
       <p:ext uri="{BB962C8B-B14F-4D97-AF65-F5344CB8AC3E}">
-        <p14:creationId xmlns:p14="http://schemas.microsoft.com/office/powerpoint/2010/main" val="184801336"/>
+        <p14:creationId xmlns:p14="http://schemas.microsoft.com/office/powerpoint/2010/main" val="67675782"/>
       </p:ext>
     </p:extLst>
   </p:cSld>
@@ -17752,7 +17819,7 @@
           <p:cNvPr id="2" name="Title 1">
             <a:extLst>
               <a:ext uri="{FF2B5EF4-FFF2-40B4-BE49-F238E27FC236}">
-                <a16:creationId xmlns:a16="http://schemas.microsoft.com/office/drawing/2014/main" id="{3451078B-7BA4-2FB9-8D35-283E519841F8}"/>
+                <a16:creationId xmlns:a16="http://schemas.microsoft.com/office/drawing/2014/main" id="{4C233810-2BA1-BBFF-C4AF-A6B03EABC814}"/>
               </a:ext>
             </a:extLst>
           </p:cNvPr>
@@ -17780,7 +17847,7 @@
           <p:cNvPr id="3" name="Content Placeholder 2">
             <a:extLst>
               <a:ext uri="{FF2B5EF4-FFF2-40B4-BE49-F238E27FC236}">
-                <a16:creationId xmlns:a16="http://schemas.microsoft.com/office/drawing/2014/main" id="{BDF0C8BC-A5C4-AD5D-2B7F-B148D85577DF}"/>
+                <a16:creationId xmlns:a16="http://schemas.microsoft.com/office/drawing/2014/main" id="{C2C7BE89-9A11-492D-92EE-899492E00DA3}"/>
               </a:ext>
             </a:extLst>
           </p:cNvPr>
@@ -17808,7 +17875,7 @@
             </a:pPr>
             <a:r>
               <a:rPr lang="en-US" sz="1600"/>
-              <a:t>Draw the histogram using the five bins from the frequency table.</a:t>
+              <a:t>Draw the histogram using the four bins from the frequency table.</a:t>
             </a:r>
           </a:p>
           <a:p>
@@ -17819,7 +17886,7 @@
               <a:rPr lang="en-US" sz="1600">
                 <a:latin typeface="Consolas" panose="020B0609020204030204" pitchFamily="49" charset="0"/>
               </a:rPr>
-              <a:t>x = { 45,  51,  52,  56,  77,  78,  78,  78,  79,  84 }</a:t>
+              <a:t>x = { 68,  72,  76,  76,  76,  83,  85,  87,  92,  95 }</a:t>
             </a:r>
           </a:p>
         </p:txBody>
@@ -17829,7 +17896,7 @@
           <p:cNvPr id="5" name="Picture 4">
             <a:extLst>
               <a:ext uri="{FF2B5EF4-FFF2-40B4-BE49-F238E27FC236}">
-                <a16:creationId xmlns:a16="http://schemas.microsoft.com/office/drawing/2014/main" id="{9422DD68-8DA5-D0FE-DA7A-3D50ED3AFA25}"/>
+                <a16:creationId xmlns:a16="http://schemas.microsoft.com/office/drawing/2014/main" id="{BF7C214F-F2DD-3FBF-2BA2-0ACDBD8DD428}"/>
               </a:ext>
             </a:extLst>
           </p:cNvPr>
@@ -17863,7 +17930,7 @@
     </p:spTree>
     <p:extLst>
       <p:ext uri="{BB962C8B-B14F-4D97-AF65-F5344CB8AC3E}">
-        <p14:creationId xmlns:p14="http://schemas.microsoft.com/office/powerpoint/2010/main" val="432316385"/>
+        <p14:creationId xmlns:p14="http://schemas.microsoft.com/office/powerpoint/2010/main" val="1039857790"/>
       </p:ext>
     </p:extLst>
   </p:cSld>
@@ -18029,7 +18096,7 @@
           <p:cNvPr id="2" name="Title 1">
             <a:extLst>
               <a:ext uri="{FF2B5EF4-FFF2-40B4-BE49-F238E27FC236}">
-                <a16:creationId xmlns:a16="http://schemas.microsoft.com/office/drawing/2014/main" id="{F8F173EA-121A-2F41-A73E-7CFE7991B044}"/>
+                <a16:creationId xmlns:a16="http://schemas.microsoft.com/office/drawing/2014/main" id="{001C9DB3-F6DF-A637-1E82-3A0AEC330394}"/>
               </a:ext>
             </a:extLst>
           </p:cNvPr>
@@ -18057,7 +18124,7 @@
           <p:cNvPr id="3" name="Content Placeholder 2">
             <a:extLst>
               <a:ext uri="{FF2B5EF4-FFF2-40B4-BE49-F238E27FC236}">
-                <a16:creationId xmlns:a16="http://schemas.microsoft.com/office/drawing/2014/main" id="{8844EDC5-46AE-3590-51DE-DAB87611EB65}"/>
+                <a16:creationId xmlns:a16="http://schemas.microsoft.com/office/drawing/2014/main" id="{C651B011-D291-C98B-272F-10A4905F450D}"/>
               </a:ext>
             </a:extLst>
           </p:cNvPr>
@@ -18077,39 +18144,32 @@
           <a:p>
             <a:r>
               <a:rPr lang="en-US" sz="1700"/>
-              <a:t>All three show the same gap: not one waiting time between 60 and 70 minutes</a:t>
-            </a:r>
-          </a:p>
-          <a:p>
+              <a:t>All three show the same shape: a peak in the 70s with a tail running up into the 90s</a:t>
+            </a:r>
+          </a:p>
+          <a:p>
+            <a:pPr lvl="1"/>
             <a:r>
               <a:rPr lang="en-US" sz="1700"/>
-              <a:t>Two clusters, around 50 minutes and around 78</a:t>
-            </a:r>
-          </a:p>
-          <a:p>
-            <a:pPr lvl="1"/>
+              <a:t>That is skewed right, the shape we met on Wednesday</a:t>
+            </a:r>
+          </a:p>
+          <a:p>
             <a:r>
               <a:rPr lang="en-US" sz="1700"/>
-              <a:t>The same two humps we saw on Wednesday in all 272 eruptions</a:t>
+              <a:t>Three games tie at 76, so the plots have a clear tallest point</a:t>
             </a:r>
           </a:p>
           <a:p>
             <a:r>
               <a:rPr lang="en-US" sz="1700"/>
-              <a:t>But with n = 10 the shape is faint. With n = 272 it was unmistakable</a:t>
-            </a:r>
-          </a:p>
-          <a:p>
-            <a:pPr lvl="1"/>
+              <a:t>But how skewed? Where exactly is the center? The picture will not say</a:t>
+            </a:r>
+          </a:p>
+          <a:p>
             <a:r>
               <a:rPr lang="en-US" sz="1700"/>
-              <a:t>A small sample can hide a feature that is really there</a:t>
-            </a:r>
-          </a:p>
-          <a:p>
-            <a:r>
-              <a:rPr lang="en-US" sz="1700"/>
-              <a:t>So eyeballing a picture only takes us so far. Now we compute numbers</a:t>
+              <a:t>Eyeballing a plot gets us the shape. Numbers make it precise</a:t>
             </a:r>
           </a:p>
           <a:p>
@@ -18131,7 +18191,7 @@
     </p:spTree>
     <p:extLst>
       <p:ext uri="{BB962C8B-B14F-4D97-AF65-F5344CB8AC3E}">
-        <p14:creationId xmlns:p14="http://schemas.microsoft.com/office/powerpoint/2010/main" val="3598768133"/>
+        <p14:creationId xmlns:p14="http://schemas.microsoft.com/office/powerpoint/2010/main" val="2260463354"/>
       </p:ext>
     </p:extLst>
   </p:cSld>
@@ -18574,7 +18634,7 @@
     </p:spTree>
     <p:extLst>
       <p:ext uri="{BB962C8B-B14F-4D97-AF65-F5344CB8AC3E}">
-        <p14:creationId xmlns:p14="http://schemas.microsoft.com/office/powerpoint/2010/main" val="1909890601"/>
+        <p14:creationId xmlns:p14="http://schemas.microsoft.com/office/powerpoint/2010/main" val="955869114"/>
       </p:ext>
     </p:extLst>
   </p:cSld>
@@ -18731,7 +18791,7 @@
     </p:spTree>
     <p:extLst>
       <p:ext uri="{BB962C8B-B14F-4D97-AF65-F5344CB8AC3E}">
-        <p14:creationId xmlns:p14="http://schemas.microsoft.com/office/powerpoint/2010/main" val="270827147"/>
+        <p14:creationId xmlns:p14="http://schemas.microsoft.com/office/powerpoint/2010/main" val="828261146"/>
       </p:ext>
     </p:extLst>
   </p:cSld>

</xml_diff>